<commit_message>
Update rates plots to reflect current results
</commit_message>
<xml_diff>
--- a/img/rates_full.pptx
+++ b/img/rates_full.pptx
@@ -254,7 +254,7 @@
           <a:p>
             <a:fld id="{918BE157-C9BD-DB4B-B849-501D8C18A188}" type="datetimeFigureOut">
               <a:rPr lang="en-US" smtClean="0"/>
-              <a:t>9/9/26</a:t>
+              <a:t>9/29/26</a:t>
             </a:fld>
             <a:endParaRPr lang="en-US"/>
           </a:p>
@@ -424,7 +424,7 @@
           <a:p>
             <a:fld id="{918BE157-C9BD-DB4B-B849-501D8C18A188}" type="datetimeFigureOut">
               <a:rPr lang="en-US" smtClean="0"/>
-              <a:t>9/9/26</a:t>
+              <a:t>9/29/26</a:t>
             </a:fld>
             <a:endParaRPr lang="en-US"/>
           </a:p>
@@ -604,7 +604,7 @@
           <a:p>
             <a:fld id="{918BE157-C9BD-DB4B-B849-501D8C18A188}" type="datetimeFigureOut">
               <a:rPr lang="en-US" smtClean="0"/>
-              <a:t>9/9/26</a:t>
+              <a:t>9/29/26</a:t>
             </a:fld>
             <a:endParaRPr lang="en-US"/>
           </a:p>
@@ -774,7 +774,7 @@
           <a:p>
             <a:fld id="{918BE157-C9BD-DB4B-B849-501D8C18A188}" type="datetimeFigureOut">
               <a:rPr lang="en-US" smtClean="0"/>
-              <a:t>9/9/26</a:t>
+              <a:t>9/29/26</a:t>
             </a:fld>
             <a:endParaRPr lang="en-US"/>
           </a:p>
@@ -1020,7 +1020,7 @@
           <a:p>
             <a:fld id="{918BE157-C9BD-DB4B-B849-501D8C18A188}" type="datetimeFigureOut">
               <a:rPr lang="en-US" smtClean="0"/>
-              <a:t>9/9/26</a:t>
+              <a:t>9/29/26</a:t>
             </a:fld>
             <a:endParaRPr lang="en-US"/>
           </a:p>
@@ -1252,7 +1252,7 @@
           <a:p>
             <a:fld id="{918BE157-C9BD-DB4B-B849-501D8C18A188}" type="datetimeFigureOut">
               <a:rPr lang="en-US" smtClean="0"/>
-              <a:t>9/9/26</a:t>
+              <a:t>9/29/26</a:t>
             </a:fld>
             <a:endParaRPr lang="en-US"/>
           </a:p>
@@ -1619,7 +1619,7 @@
           <a:p>
             <a:fld id="{918BE157-C9BD-DB4B-B849-501D8C18A188}" type="datetimeFigureOut">
               <a:rPr lang="en-US" smtClean="0"/>
-              <a:t>9/9/26</a:t>
+              <a:t>9/29/26</a:t>
             </a:fld>
             <a:endParaRPr lang="en-US"/>
           </a:p>
@@ -1737,7 +1737,7 @@
           <a:p>
             <a:fld id="{918BE157-C9BD-DB4B-B849-501D8C18A188}" type="datetimeFigureOut">
               <a:rPr lang="en-US" smtClean="0"/>
-              <a:t>9/9/26</a:t>
+              <a:t>9/29/26</a:t>
             </a:fld>
             <a:endParaRPr lang="en-US"/>
           </a:p>
@@ -1832,7 +1832,7 @@
           <a:p>
             <a:fld id="{918BE157-C9BD-DB4B-B849-501D8C18A188}" type="datetimeFigureOut">
               <a:rPr lang="en-US" smtClean="0"/>
-              <a:t>9/9/26</a:t>
+              <a:t>9/29/26</a:t>
             </a:fld>
             <a:endParaRPr lang="en-US"/>
           </a:p>
@@ -2109,7 +2109,7 @@
           <a:p>
             <a:fld id="{918BE157-C9BD-DB4B-B849-501D8C18A188}" type="datetimeFigureOut">
               <a:rPr lang="en-US" smtClean="0"/>
-              <a:t>9/9/26</a:t>
+              <a:t>9/29/26</a:t>
             </a:fld>
             <a:endParaRPr lang="en-US"/>
           </a:p>
@@ -2366,7 +2366,7 @@
           <a:p>
             <a:fld id="{918BE157-C9BD-DB4B-B849-501D8C18A188}" type="datetimeFigureOut">
               <a:rPr lang="en-US" smtClean="0"/>
-              <a:t>9/9/26</a:t>
+              <a:t>9/29/26</a:t>
             </a:fld>
             <a:endParaRPr lang="en-US"/>
           </a:p>
@@ -2579,7 +2579,7 @@
           <a:p>
             <a:fld id="{918BE157-C9BD-DB4B-B849-501D8C18A188}" type="datetimeFigureOut">
               <a:rPr lang="en-US" smtClean="0"/>
-              <a:t>9/9/26</a:t>
+              <a:t>9/29/26</a:t>
             </a:fld>
             <a:endParaRPr lang="en-US"/>
           </a:p>
@@ -3172,7 +3172,7 @@
           <a:prstGeom prst="straightConnector1">
             <a:avLst/>
           </a:prstGeom>
-          <a:ln w="17018">
+          <a:ln w="16510">
             <a:headEnd type="none" w="med" len="med"/>
             <a:tailEnd type="stealth" w="lg" len="med"/>
           </a:ln>
@@ -3214,7 +3214,7 @@
           <a:prstGeom prst="straightConnector1">
             <a:avLst/>
           </a:prstGeom>
-          <a:ln w="51561">
+          <a:ln w="52069">
             <a:headEnd type="none" w="med" len="med"/>
             <a:tailEnd type="stealth" w="med" len="med"/>
           </a:ln>
@@ -3256,7 +3256,7 @@
           <a:prstGeom prst="straightConnector1">
             <a:avLst/>
           </a:prstGeom>
-          <a:ln w="29337">
+          <a:ln w="29209">
             <a:headEnd type="none" w="med" len="med"/>
             <a:tailEnd type="stealth" w="lg" len="med"/>
           </a:ln>
@@ -3298,7 +3298,7 @@
           <a:prstGeom prst="straightConnector1">
             <a:avLst/>
           </a:prstGeom>
-          <a:ln w="23749">
+          <a:ln w="24130">
             <a:headEnd type="none" w="med" len="med"/>
             <a:tailEnd type="stealth" w="lg" len="med"/>
           </a:ln>
@@ -3341,7 +3341,7 @@
               <a:gd name="adj2" fmla="val 20776843"/>
             </a:avLst>
           </a:prstGeom>
-          <a:ln w="21844">
+          <a:ln w="21590">
             <a:headEnd type="none" w="med" len="med"/>
             <a:tailEnd type="stealth" w="lg" len="med"/>
           </a:ln>
@@ -3401,7 +3401,7 @@
               <a:rPr lang="en-US" sz="1200" dirty="0">
                 <a:latin typeface="Helvetica" pitchFamily="2" charset="0"/>
               </a:rPr>
-              <a:t>0.13 [0.08 0.25]</a:t>
+              <a:t>0.13 [0.08 0.24]</a:t>
             </a:r>
           </a:p>
         </p:txBody>
@@ -3438,7 +3438,7 @@
               <a:rPr lang="en-US" sz="1200" dirty="0">
                 <a:latin typeface="Helvetica" pitchFamily="2" charset="0"/>
               </a:rPr>
-              <a:t>0.41 [0.20 0.86]</a:t>
+              <a:t>0.41 [0.20 0.85]</a:t>
             </a:r>
           </a:p>
         </p:txBody>
@@ -3475,7 +3475,7 @@
               <a:rPr lang="en-US" sz="1200" dirty="0">
                 <a:latin typeface="Helvetica" pitchFamily="2" charset="0"/>
               </a:rPr>
-              <a:t>0.23 [0.04 0.68]</a:t>
+              <a:t>0.23 [0.04 0.66]</a:t>
             </a:r>
           </a:p>
         </p:txBody>
@@ -3512,7 +3512,7 @@
               <a:rPr lang="en-US" sz="1200" dirty="0">
                 <a:latin typeface="Helvetica" pitchFamily="2" charset="0"/>
               </a:rPr>
-              <a:t>0.19 [0.10 0.39]</a:t>
+              <a:t>0.19 [0.10 0.38]</a:t>
             </a:r>
           </a:p>
         </p:txBody>
@@ -3549,7 +3549,7 @@
               <a:rPr lang="en-US" sz="1200" dirty="0">
                 <a:latin typeface="Helvetica" pitchFamily="2" charset="0"/>
               </a:rPr>
-              <a:t>0.17 [0.09 0.27]</a:t>
+              <a:t>0.17 [0.08 0.27]</a:t>
             </a:r>
           </a:p>
         </p:txBody>
@@ -3691,7 +3691,7 @@
               <a:gd name="adj2" fmla="val 20776843"/>
             </a:avLst>
           </a:prstGeom>
-          <a:ln w="4699">
+          <a:ln w="5080">
             <a:headEnd type="none" w="med" len="med"/>
             <a:tailEnd type="stealth" w="lg" len="med"/>
           </a:ln>

</xml_diff>

<commit_message>
Use phylogenetic clades for world regions
</commit_message>
<xml_diff>
--- a/img/rates_full.pptx
+++ b/img/rates_full.pptx
@@ -254,7 +254,7 @@
           <a:p>
             <a:fld id="{918BE157-C9BD-DB4B-B849-501D8C18A188}" type="datetimeFigureOut">
               <a:rPr lang="en-US" smtClean="0"/>
-              <a:t>9/29/26</a:t>
+              <a:t>9/30/26</a:t>
             </a:fld>
             <a:endParaRPr lang="en-US"/>
           </a:p>
@@ -424,7 +424,7 @@
           <a:p>
             <a:fld id="{918BE157-C9BD-DB4B-B849-501D8C18A188}" type="datetimeFigureOut">
               <a:rPr lang="en-US" smtClean="0"/>
-              <a:t>9/29/26</a:t>
+              <a:t>9/30/26</a:t>
             </a:fld>
             <a:endParaRPr lang="en-US"/>
           </a:p>
@@ -604,7 +604,7 @@
           <a:p>
             <a:fld id="{918BE157-C9BD-DB4B-B849-501D8C18A188}" type="datetimeFigureOut">
               <a:rPr lang="en-US" smtClean="0"/>
-              <a:t>9/29/26</a:t>
+              <a:t>9/30/26</a:t>
             </a:fld>
             <a:endParaRPr lang="en-US"/>
           </a:p>
@@ -774,7 +774,7 @@
           <a:p>
             <a:fld id="{918BE157-C9BD-DB4B-B849-501D8C18A188}" type="datetimeFigureOut">
               <a:rPr lang="en-US" smtClean="0"/>
-              <a:t>9/29/26</a:t>
+              <a:t>9/30/26</a:t>
             </a:fld>
             <a:endParaRPr lang="en-US"/>
           </a:p>
@@ -1020,7 +1020,7 @@
           <a:p>
             <a:fld id="{918BE157-C9BD-DB4B-B849-501D8C18A188}" type="datetimeFigureOut">
               <a:rPr lang="en-US" smtClean="0"/>
-              <a:t>9/29/26</a:t>
+              <a:t>9/30/26</a:t>
             </a:fld>
             <a:endParaRPr lang="en-US"/>
           </a:p>
@@ -1252,7 +1252,7 @@
           <a:p>
             <a:fld id="{918BE157-C9BD-DB4B-B849-501D8C18A188}" type="datetimeFigureOut">
               <a:rPr lang="en-US" smtClean="0"/>
-              <a:t>9/29/26</a:t>
+              <a:t>9/30/26</a:t>
             </a:fld>
             <a:endParaRPr lang="en-US"/>
           </a:p>
@@ -1619,7 +1619,7 @@
           <a:p>
             <a:fld id="{918BE157-C9BD-DB4B-B849-501D8C18A188}" type="datetimeFigureOut">
               <a:rPr lang="en-US" smtClean="0"/>
-              <a:t>9/29/26</a:t>
+              <a:t>9/30/26</a:t>
             </a:fld>
             <a:endParaRPr lang="en-US"/>
           </a:p>
@@ -1737,7 +1737,7 @@
           <a:p>
             <a:fld id="{918BE157-C9BD-DB4B-B849-501D8C18A188}" type="datetimeFigureOut">
               <a:rPr lang="en-US" smtClean="0"/>
-              <a:t>9/29/26</a:t>
+              <a:t>9/30/26</a:t>
             </a:fld>
             <a:endParaRPr lang="en-US"/>
           </a:p>
@@ -1832,7 +1832,7 @@
           <a:p>
             <a:fld id="{918BE157-C9BD-DB4B-B849-501D8C18A188}" type="datetimeFigureOut">
               <a:rPr lang="en-US" smtClean="0"/>
-              <a:t>9/29/26</a:t>
+              <a:t>9/30/26</a:t>
             </a:fld>
             <a:endParaRPr lang="en-US"/>
           </a:p>
@@ -2109,7 +2109,7 @@
           <a:p>
             <a:fld id="{918BE157-C9BD-DB4B-B849-501D8C18A188}" type="datetimeFigureOut">
               <a:rPr lang="en-US" smtClean="0"/>
-              <a:t>9/29/26</a:t>
+              <a:t>9/30/26</a:t>
             </a:fld>
             <a:endParaRPr lang="en-US"/>
           </a:p>
@@ -2366,7 +2366,7 @@
           <a:p>
             <a:fld id="{918BE157-C9BD-DB4B-B849-501D8C18A188}" type="datetimeFigureOut">
               <a:rPr lang="en-US" smtClean="0"/>
-              <a:t>9/29/26</a:t>
+              <a:t>9/30/26</a:t>
             </a:fld>
             <a:endParaRPr lang="en-US"/>
           </a:p>
@@ -2579,7 +2579,7 @@
           <a:p>
             <a:fld id="{918BE157-C9BD-DB4B-B849-501D8C18A188}" type="datetimeFigureOut">
               <a:rPr lang="en-US" smtClean="0"/>
-              <a:t>9/29/26</a:t>
+              <a:t>9/30/26</a:t>
             </a:fld>
             <a:endParaRPr lang="en-US"/>
           </a:p>
@@ -3172,7 +3172,7 @@
           <a:prstGeom prst="straightConnector1">
             <a:avLst/>
           </a:prstGeom>
-          <a:ln w="16510">
+          <a:ln w="17780">
             <a:headEnd type="none" w="med" len="med"/>
             <a:tailEnd type="stealth" w="lg" len="med"/>
           </a:ln>
@@ -3401,7 +3401,7 @@
               <a:rPr lang="en-US" sz="1200" dirty="0">
                 <a:latin typeface="Helvetica" pitchFamily="2" charset="0"/>
               </a:rPr>
-              <a:t>0.13 [0.08 0.24]</a:t>
+              <a:t>0.14 [0.08 0.25]</a:t>
             </a:r>
           </a:p>
         </p:txBody>
@@ -3438,7 +3438,7 @@
               <a:rPr lang="en-US" sz="1200" dirty="0">
                 <a:latin typeface="Helvetica" pitchFamily="2" charset="0"/>
               </a:rPr>
-              <a:t>0.41 [0.20 0.85]</a:t>
+              <a:t>0.41 [0.20 0.84]</a:t>
             </a:r>
           </a:p>
         </p:txBody>
@@ -3475,7 +3475,7 @@
               <a:rPr lang="en-US" sz="1200" dirty="0">
                 <a:latin typeface="Helvetica" pitchFamily="2" charset="0"/>
               </a:rPr>
-              <a:t>0.23 [0.04 0.66]</a:t>
+              <a:t>0.23 [0.04 0.68]</a:t>
             </a:r>
           </a:p>
         </p:txBody>
@@ -3512,7 +3512,7 @@
               <a:rPr lang="en-US" sz="1200" dirty="0">
                 <a:latin typeface="Helvetica" pitchFamily="2" charset="0"/>
               </a:rPr>
-              <a:t>0.19 [0.10 0.38]</a:t>
+              <a:t>0.19 [0.10 0.39]</a:t>
             </a:r>
           </a:p>
         </p:txBody>
@@ -3751,7 +3751,7 @@
               <a:rPr lang="en-US" sz="1200" dirty="0">
                 <a:latin typeface="Helvetica" pitchFamily="2" charset="0"/>
               </a:rPr>
-              <a:t>0.04 [0.01 0.09]</a:t>
+              <a:t>0.04 [0.00 0.09]</a:t>
             </a:r>
           </a:p>
         </p:txBody>

</xml_diff>